<commit_message>
Added confidentiality footer to markdowns
Co-authored-by: Myrhythm0106 <211762774+Myrhythm0106@users.noreply.github.com>
</commit_message>
<xml_diff>
--- a/MyRhythm_Productivity_Investor_Deck_v2.pptx
+++ b/MyRhythm_Productivity_Investor_Deck_v2.pptx
@@ -2669,6 +2669,41 @@
           </a:p>
         </p:txBody>
       </p:sp>
+      <p:sp>
+        <p:nvSpPr>
+          <p:cNvPr id="10" name="TextBox 9"/>
+          <p:cNvSpPr txBox="1"/>
+          <p:nvPr/>
+        </p:nvSpPr>
+        <p:spPr>
+          <a:xfrm>
+            <a:off x="457200" y="4777740"/>
+            <a:ext cx="8229600" cy="274320"/>
+          </a:xfrm>
+          <a:prstGeom prst="rect">
+            <a:avLst/>
+          </a:prstGeom>
+          <a:noFill/>
+        </p:spPr>
+        <p:txBody>
+          <a:bodyPr wrap="square">
+            <a:spAutoFit/>
+          </a:bodyPr>
+          <a:lstStyle/>
+          <a:p>
+            <a:pPr algn="ctr">
+              <a:defRPr sz="600" i="1">
+                <a:solidFill>
+                  <a:srgbClr val="888888"/>
+                </a:solidFill>
+              </a:defRPr>
+            </a:pPr>
+            <a:r>
+              <a:t>Confidential – Not for Distribution  |  © 2026 Annabel Aaron. All rights reserved.</a:t>
+            </a:r>
+          </a:p>
+        </p:txBody>
+      </p:sp>
     </p:spTree>
   </p:cSld>
   <p:clrMapOvr>
@@ -3733,6 +3768,41 @@
           </a:p>
         </p:txBody>
       </p:sp>
+      <p:sp>
+        <p:nvSpPr>
+          <p:cNvPr id="31" name="TextBox 30"/>
+          <p:cNvSpPr txBox="1"/>
+          <p:nvPr/>
+        </p:nvSpPr>
+        <p:spPr>
+          <a:xfrm>
+            <a:off x="457200" y="4777740"/>
+            <a:ext cx="8229600" cy="274320"/>
+          </a:xfrm>
+          <a:prstGeom prst="rect">
+            <a:avLst/>
+          </a:prstGeom>
+          <a:noFill/>
+        </p:spPr>
+        <p:txBody>
+          <a:bodyPr wrap="square">
+            <a:spAutoFit/>
+          </a:bodyPr>
+          <a:lstStyle/>
+          <a:p>
+            <a:pPr algn="ctr">
+              <a:defRPr sz="600" i="1">
+                <a:solidFill>
+                  <a:srgbClr val="888888"/>
+                </a:solidFill>
+              </a:defRPr>
+            </a:pPr>
+            <a:r>
+              <a:t>Confidential – Not for Distribution  |  © 2026 Annabel Aaron. All rights reserved.</a:t>
+            </a:r>
+          </a:p>
+        </p:txBody>
+      </p:sp>
     </p:spTree>
   </p:cSld>
   <p:clrMapOvr>
@@ -4221,6 +4291,41 @@
           </a:p>
         </p:txBody>
       </p:sp>
+      <p:sp>
+        <p:nvSpPr>
+          <p:cNvPr id="14" name="TextBox 13"/>
+          <p:cNvSpPr txBox="1"/>
+          <p:nvPr/>
+        </p:nvSpPr>
+        <p:spPr>
+          <a:xfrm>
+            <a:off x="457200" y="4777740"/>
+            <a:ext cx="8229600" cy="274320"/>
+          </a:xfrm>
+          <a:prstGeom prst="rect">
+            <a:avLst/>
+          </a:prstGeom>
+          <a:noFill/>
+        </p:spPr>
+        <p:txBody>
+          <a:bodyPr wrap="square">
+            <a:spAutoFit/>
+          </a:bodyPr>
+          <a:lstStyle/>
+          <a:p>
+            <a:pPr algn="ctr">
+              <a:defRPr sz="600" i="1">
+                <a:solidFill>
+                  <a:srgbClr val="888888"/>
+                </a:solidFill>
+              </a:defRPr>
+            </a:pPr>
+            <a:r>
+              <a:t>Confidential – Not for Distribution  |  © 2026 Annabel Aaron. All rights reserved.</a:t>
+            </a:r>
+          </a:p>
+        </p:txBody>
+      </p:sp>
     </p:spTree>
   </p:cSld>
   <p:clrMapOvr>
@@ -4669,6 +4774,41 @@
           </a:p>
         </p:txBody>
       </p:sp>
+      <p:sp>
+        <p:nvSpPr>
+          <p:cNvPr id="15" name="TextBox 14"/>
+          <p:cNvSpPr txBox="1"/>
+          <p:nvPr/>
+        </p:nvSpPr>
+        <p:spPr>
+          <a:xfrm>
+            <a:off x="457200" y="4777740"/>
+            <a:ext cx="8229600" cy="274320"/>
+          </a:xfrm>
+          <a:prstGeom prst="rect">
+            <a:avLst/>
+          </a:prstGeom>
+          <a:noFill/>
+        </p:spPr>
+        <p:txBody>
+          <a:bodyPr wrap="square">
+            <a:spAutoFit/>
+          </a:bodyPr>
+          <a:lstStyle/>
+          <a:p>
+            <a:pPr algn="ctr">
+              <a:defRPr sz="600" i="1">
+                <a:solidFill>
+                  <a:srgbClr val="888888"/>
+                </a:solidFill>
+              </a:defRPr>
+            </a:pPr>
+            <a:r>
+              <a:t>Confidential – Not for Distribution  |  © 2026 Annabel Aaron. All rights reserved.</a:t>
+            </a:r>
+          </a:p>
+        </p:txBody>
+      </p:sp>
     </p:spTree>
   </p:cSld>
   <p:clrMapOvr>
@@ -5585,6 +5725,41 @@
           </a:p>
         </p:txBody>
       </p:sp>
+      <p:sp>
+        <p:nvSpPr>
+          <p:cNvPr id="26" name="TextBox 25"/>
+          <p:cNvSpPr txBox="1"/>
+          <p:nvPr/>
+        </p:nvSpPr>
+        <p:spPr>
+          <a:xfrm>
+            <a:off x="457200" y="4777740"/>
+            <a:ext cx="8229600" cy="274320"/>
+          </a:xfrm>
+          <a:prstGeom prst="rect">
+            <a:avLst/>
+          </a:prstGeom>
+          <a:noFill/>
+        </p:spPr>
+        <p:txBody>
+          <a:bodyPr wrap="square">
+            <a:spAutoFit/>
+          </a:bodyPr>
+          <a:lstStyle/>
+          <a:p>
+            <a:pPr algn="ctr">
+              <a:defRPr sz="600" i="1">
+                <a:solidFill>
+                  <a:srgbClr val="888888"/>
+                </a:solidFill>
+              </a:defRPr>
+            </a:pPr>
+            <a:r>
+              <a:t>Confidential – Not for Distribution  |  © 2026 Annabel Aaron. All rights reserved.</a:t>
+            </a:r>
+          </a:p>
+        </p:txBody>
+      </p:sp>
     </p:spTree>
   </p:cSld>
   <p:clrMapOvr>
@@ -6434,6 +6609,41 @@
           </a:p>
         </p:txBody>
       </p:sp>
+      <p:sp>
+        <p:nvSpPr>
+          <p:cNvPr id="25" name="TextBox 24"/>
+          <p:cNvSpPr txBox="1"/>
+          <p:nvPr/>
+        </p:nvSpPr>
+        <p:spPr>
+          <a:xfrm>
+            <a:off x="457200" y="4777740"/>
+            <a:ext cx="8229600" cy="274320"/>
+          </a:xfrm>
+          <a:prstGeom prst="rect">
+            <a:avLst/>
+          </a:prstGeom>
+          <a:noFill/>
+        </p:spPr>
+        <p:txBody>
+          <a:bodyPr wrap="square">
+            <a:spAutoFit/>
+          </a:bodyPr>
+          <a:lstStyle/>
+          <a:p>
+            <a:pPr algn="ctr">
+              <a:defRPr sz="600" i="1">
+                <a:solidFill>
+                  <a:srgbClr val="888888"/>
+                </a:solidFill>
+              </a:defRPr>
+            </a:pPr>
+            <a:r>
+              <a:t>Confidential – Not for Distribution  |  © 2026 Annabel Aaron. All rights reserved.</a:t>
+            </a:r>
+          </a:p>
+        </p:txBody>
+      </p:sp>
     </p:spTree>
   </p:cSld>
   <p:clrMapOvr>
@@ -7281,6 +7491,41 @@
           </a:p>
         </p:txBody>
       </p:sp>
+      <p:sp>
+        <p:nvSpPr>
+          <p:cNvPr id="26" name="TextBox 25"/>
+          <p:cNvSpPr txBox="1"/>
+          <p:nvPr/>
+        </p:nvSpPr>
+        <p:spPr>
+          <a:xfrm>
+            <a:off x="457200" y="4777740"/>
+            <a:ext cx="8229600" cy="274320"/>
+          </a:xfrm>
+          <a:prstGeom prst="rect">
+            <a:avLst/>
+          </a:prstGeom>
+          <a:noFill/>
+        </p:spPr>
+        <p:txBody>
+          <a:bodyPr wrap="square">
+            <a:spAutoFit/>
+          </a:bodyPr>
+          <a:lstStyle/>
+          <a:p>
+            <a:pPr algn="ctr">
+              <a:defRPr sz="600" i="1">
+                <a:solidFill>
+                  <a:srgbClr val="888888"/>
+                </a:solidFill>
+              </a:defRPr>
+            </a:pPr>
+            <a:r>
+              <a:t>Confidential – Not for Distribution  |  © 2026 Annabel Aaron. All rights reserved.</a:t>
+            </a:r>
+          </a:p>
+        </p:txBody>
+      </p:sp>
     </p:spTree>
   </p:cSld>
   <p:clrMapOvr>
@@ -8409,6 +8654,41 @@
           </a:p>
         </p:txBody>
       </p:sp>
+      <p:sp>
+        <p:nvSpPr>
+          <p:cNvPr id="34" name="TextBox 33"/>
+          <p:cNvSpPr txBox="1"/>
+          <p:nvPr/>
+        </p:nvSpPr>
+        <p:spPr>
+          <a:xfrm>
+            <a:off x="457200" y="4777740"/>
+            <a:ext cx="8229600" cy="274320"/>
+          </a:xfrm>
+          <a:prstGeom prst="rect">
+            <a:avLst/>
+          </a:prstGeom>
+          <a:noFill/>
+        </p:spPr>
+        <p:txBody>
+          <a:bodyPr wrap="square">
+            <a:spAutoFit/>
+          </a:bodyPr>
+          <a:lstStyle/>
+          <a:p>
+            <a:pPr algn="ctr">
+              <a:defRPr sz="600" i="1">
+                <a:solidFill>
+                  <a:srgbClr val="888888"/>
+                </a:solidFill>
+              </a:defRPr>
+            </a:pPr>
+            <a:r>
+              <a:t>Confidential – Not for Distribution  |  © 2026 Annabel Aaron. All rights reserved.</a:t>
+            </a:r>
+          </a:p>
+        </p:txBody>
+      </p:sp>
     </p:spTree>
   </p:cSld>
   <p:clrMapOvr>
@@ -8910,6 +9190,41 @@
           </a:p>
         </p:txBody>
       </p:sp>
+      <p:sp>
+        <p:nvSpPr>
+          <p:cNvPr id="15" name="TextBox 14"/>
+          <p:cNvSpPr txBox="1"/>
+          <p:nvPr/>
+        </p:nvSpPr>
+        <p:spPr>
+          <a:xfrm>
+            <a:off x="457200" y="4777740"/>
+            <a:ext cx="8229600" cy="274320"/>
+          </a:xfrm>
+          <a:prstGeom prst="rect">
+            <a:avLst/>
+          </a:prstGeom>
+          <a:noFill/>
+        </p:spPr>
+        <p:txBody>
+          <a:bodyPr wrap="square">
+            <a:spAutoFit/>
+          </a:bodyPr>
+          <a:lstStyle/>
+          <a:p>
+            <a:pPr algn="ctr">
+              <a:defRPr sz="600" i="1">
+                <a:solidFill>
+                  <a:srgbClr val="888888"/>
+                </a:solidFill>
+              </a:defRPr>
+            </a:pPr>
+            <a:r>
+              <a:t>Confidential – Not for Distribution  |  © 2026 Annabel Aaron. All rights reserved.</a:t>
+            </a:r>
+          </a:p>
+        </p:txBody>
+      </p:sp>
     </p:spTree>
   </p:cSld>
   <p:clrMapOvr>
@@ -10160,6 +10475,41 @@
           </a:p>
         </p:txBody>
       </p:sp>
+      <p:sp>
+        <p:nvSpPr>
+          <p:cNvPr id="33" name="TextBox 32"/>
+          <p:cNvSpPr txBox="1"/>
+          <p:nvPr/>
+        </p:nvSpPr>
+        <p:spPr>
+          <a:xfrm>
+            <a:off x="457200" y="4777740"/>
+            <a:ext cx="8229600" cy="274320"/>
+          </a:xfrm>
+          <a:prstGeom prst="rect">
+            <a:avLst/>
+          </a:prstGeom>
+          <a:noFill/>
+        </p:spPr>
+        <p:txBody>
+          <a:bodyPr wrap="square">
+            <a:spAutoFit/>
+          </a:bodyPr>
+          <a:lstStyle/>
+          <a:p>
+            <a:pPr algn="ctr">
+              <a:defRPr sz="600" i="1">
+                <a:solidFill>
+                  <a:srgbClr val="888888"/>
+                </a:solidFill>
+              </a:defRPr>
+            </a:pPr>
+            <a:r>
+              <a:t>Confidential – Not for Distribution  |  © 2026 Annabel Aaron. All rights reserved.</a:t>
+            </a:r>
+          </a:p>
+        </p:txBody>
+      </p:sp>
     </p:spTree>
   </p:cSld>
   <p:clrMapOvr>
@@ -10575,6 +10925,41 @@
           </a:p>
         </p:txBody>
       </p:sp>
+      <p:sp>
+        <p:nvSpPr>
+          <p:cNvPr id="11" name="TextBox 10"/>
+          <p:cNvSpPr txBox="1"/>
+          <p:nvPr/>
+        </p:nvSpPr>
+        <p:spPr>
+          <a:xfrm>
+            <a:off x="457200" y="4777740"/>
+            <a:ext cx="8229600" cy="274320"/>
+          </a:xfrm>
+          <a:prstGeom prst="rect">
+            <a:avLst/>
+          </a:prstGeom>
+          <a:noFill/>
+        </p:spPr>
+        <p:txBody>
+          <a:bodyPr wrap="square">
+            <a:spAutoFit/>
+          </a:bodyPr>
+          <a:lstStyle/>
+          <a:p>
+            <a:pPr algn="ctr">
+              <a:defRPr sz="600" i="1">
+                <a:solidFill>
+                  <a:srgbClr val="888888"/>
+                </a:solidFill>
+              </a:defRPr>
+            </a:pPr>
+            <a:r>
+              <a:t>Confidential – Not for Distribution  |  © 2026 Annabel Aaron. All rights reserved.</a:t>
+            </a:r>
+          </a:p>
+        </p:txBody>
+      </p:sp>
     </p:spTree>
   </p:cSld>
   <p:clrMapOvr>
@@ -11308,6 +11693,41 @@
           </a:p>
         </p:txBody>
       </p:sp>
+      <p:sp>
+        <p:nvSpPr>
+          <p:cNvPr id="19" name="TextBox 18"/>
+          <p:cNvSpPr txBox="1"/>
+          <p:nvPr/>
+        </p:nvSpPr>
+        <p:spPr>
+          <a:xfrm>
+            <a:off x="457200" y="4777740"/>
+            <a:ext cx="8229600" cy="274320"/>
+          </a:xfrm>
+          <a:prstGeom prst="rect">
+            <a:avLst/>
+          </a:prstGeom>
+          <a:noFill/>
+        </p:spPr>
+        <p:txBody>
+          <a:bodyPr wrap="square">
+            <a:spAutoFit/>
+          </a:bodyPr>
+          <a:lstStyle/>
+          <a:p>
+            <a:pPr algn="ctr">
+              <a:defRPr sz="600" i="1">
+                <a:solidFill>
+                  <a:srgbClr val="888888"/>
+                </a:solidFill>
+              </a:defRPr>
+            </a:pPr>
+            <a:r>
+              <a:t>Confidential – Not for Distribution  |  © 2026 Annabel Aaron. All rights reserved.</a:t>
+            </a:r>
+          </a:p>
+        </p:txBody>
+      </p:sp>
     </p:spTree>
   </p:cSld>
   <p:clrMapOvr>
@@ -11523,6 +11943,41 @@
           </a:p>
         </p:txBody>
       </p:sp>
+      <p:sp>
+        <p:nvSpPr>
+          <p:cNvPr id="7" name="TextBox 6"/>
+          <p:cNvSpPr txBox="1"/>
+          <p:nvPr/>
+        </p:nvSpPr>
+        <p:spPr>
+          <a:xfrm>
+            <a:off x="457200" y="4777740"/>
+            <a:ext cx="8229600" cy="274320"/>
+          </a:xfrm>
+          <a:prstGeom prst="rect">
+            <a:avLst/>
+          </a:prstGeom>
+          <a:noFill/>
+        </p:spPr>
+        <p:txBody>
+          <a:bodyPr wrap="square">
+            <a:spAutoFit/>
+          </a:bodyPr>
+          <a:lstStyle/>
+          <a:p>
+            <a:pPr algn="ctr">
+              <a:defRPr sz="600" i="1">
+                <a:solidFill>
+                  <a:srgbClr val="888888"/>
+                </a:solidFill>
+              </a:defRPr>
+            </a:pPr>
+            <a:r>
+              <a:t>Confidential – Not for Distribution  |  © 2026 Annabel Aaron. All rights reserved.</a:t>
+            </a:r>
+          </a:p>
+        </p:txBody>
+      </p:sp>
     </p:spTree>
   </p:cSld>
   <p:clrMapOvr>
@@ -12517,6 +12972,41 @@
           </a:p>
         </p:txBody>
       </p:sp>
+      <p:sp>
+        <p:nvSpPr>
+          <p:cNvPr id="29" name="TextBox 28"/>
+          <p:cNvSpPr txBox="1"/>
+          <p:nvPr/>
+        </p:nvSpPr>
+        <p:spPr>
+          <a:xfrm>
+            <a:off x="457200" y="4777740"/>
+            <a:ext cx="8229600" cy="274320"/>
+          </a:xfrm>
+          <a:prstGeom prst="rect">
+            <a:avLst/>
+          </a:prstGeom>
+          <a:noFill/>
+        </p:spPr>
+        <p:txBody>
+          <a:bodyPr wrap="square">
+            <a:spAutoFit/>
+          </a:bodyPr>
+          <a:lstStyle/>
+          <a:p>
+            <a:pPr algn="ctr">
+              <a:defRPr sz="600" i="1">
+                <a:solidFill>
+                  <a:srgbClr val="888888"/>
+                </a:solidFill>
+              </a:defRPr>
+            </a:pPr>
+            <a:r>
+              <a:t>Confidential – Not for Distribution  |  © 2026 Annabel Aaron. All rights reserved.</a:t>
+            </a:r>
+          </a:p>
+        </p:txBody>
+      </p:sp>
     </p:spTree>
   </p:cSld>
   <p:clrMapOvr>
@@ -13389,6 +13879,41 @@
           </a:p>
         </p:txBody>
       </p:sp>
+      <p:sp>
+        <p:nvSpPr>
+          <p:cNvPr id="25" name="TextBox 24"/>
+          <p:cNvSpPr txBox="1"/>
+          <p:nvPr/>
+        </p:nvSpPr>
+        <p:spPr>
+          <a:xfrm>
+            <a:off x="457200" y="4777740"/>
+            <a:ext cx="8229600" cy="274320"/>
+          </a:xfrm>
+          <a:prstGeom prst="rect">
+            <a:avLst/>
+          </a:prstGeom>
+          <a:noFill/>
+        </p:spPr>
+        <p:txBody>
+          <a:bodyPr wrap="square">
+            <a:spAutoFit/>
+          </a:bodyPr>
+          <a:lstStyle/>
+          <a:p>
+            <a:pPr algn="ctr">
+              <a:defRPr sz="600" i="1">
+                <a:solidFill>
+                  <a:srgbClr val="888888"/>
+                </a:solidFill>
+              </a:defRPr>
+            </a:pPr>
+            <a:r>
+              <a:t>Confidential – Not for Distribution  |  © 2026 Annabel Aaron. All rights reserved.</a:t>
+            </a:r>
+          </a:p>
+        </p:txBody>
+      </p:sp>
     </p:spTree>
   </p:cSld>
   <p:clrMapOvr>
@@ -13646,6 +14171,41 @@
           </a:p>
         </p:txBody>
       </p:sp>
+      <p:sp>
+        <p:nvSpPr>
+          <p:cNvPr id="8" name="TextBox 7"/>
+          <p:cNvSpPr txBox="1"/>
+          <p:nvPr/>
+        </p:nvSpPr>
+        <p:spPr>
+          <a:xfrm>
+            <a:off x="457200" y="4777740"/>
+            <a:ext cx="8229600" cy="274320"/>
+          </a:xfrm>
+          <a:prstGeom prst="rect">
+            <a:avLst/>
+          </a:prstGeom>
+          <a:noFill/>
+        </p:spPr>
+        <p:txBody>
+          <a:bodyPr wrap="square">
+            <a:spAutoFit/>
+          </a:bodyPr>
+          <a:lstStyle/>
+          <a:p>
+            <a:pPr algn="ctr">
+              <a:defRPr sz="600" i="1">
+                <a:solidFill>
+                  <a:srgbClr val="888888"/>
+                </a:solidFill>
+              </a:defRPr>
+            </a:pPr>
+            <a:r>
+              <a:t>Confidential – Not for Distribution  |  © 2026 Annabel Aaron. All rights reserved.</a:t>
+            </a:r>
+          </a:p>
+        </p:txBody>
+      </p:sp>
     </p:spTree>
   </p:cSld>
   <p:clrMapOvr>
@@ -14392,6 +14952,41 @@
           </a:p>
         </p:txBody>
       </p:sp>
+      <p:sp>
+        <p:nvSpPr>
+          <p:cNvPr id="22" name="TextBox 21"/>
+          <p:cNvSpPr txBox="1"/>
+          <p:nvPr/>
+        </p:nvSpPr>
+        <p:spPr>
+          <a:xfrm>
+            <a:off x="457200" y="4777740"/>
+            <a:ext cx="8229600" cy="274320"/>
+          </a:xfrm>
+          <a:prstGeom prst="rect">
+            <a:avLst/>
+          </a:prstGeom>
+          <a:noFill/>
+        </p:spPr>
+        <p:txBody>
+          <a:bodyPr wrap="square">
+            <a:spAutoFit/>
+          </a:bodyPr>
+          <a:lstStyle/>
+          <a:p>
+            <a:pPr algn="ctr">
+              <a:defRPr sz="600" i="1">
+                <a:solidFill>
+                  <a:srgbClr val="888888"/>
+                </a:solidFill>
+              </a:defRPr>
+            </a:pPr>
+            <a:r>
+              <a:t>Confidential – Not for Distribution  |  © 2026 Annabel Aaron. All rights reserved.</a:t>
+            </a:r>
+          </a:p>
+        </p:txBody>
+      </p:sp>
     </p:spTree>
   </p:cSld>
   <p:clrMapOvr>
@@ -15050,6 +15645,41 @@
               <a:t>Every completion logged. Streaks tracked. Confidence compounds. The system proves you can be relied upon.</a:t>
             </a:r>
             <a:endParaRPr lang="en-US" sz="1100" dirty="0"/>
+          </a:p>
+        </p:txBody>
+      </p:sp>
+      <p:sp>
+        <p:nvSpPr>
+          <p:cNvPr id="20" name="TextBox 19"/>
+          <p:cNvSpPr txBox="1"/>
+          <p:nvPr/>
+        </p:nvSpPr>
+        <p:spPr>
+          <a:xfrm>
+            <a:off x="457200" y="4777740"/>
+            <a:ext cx="8229600" cy="274320"/>
+          </a:xfrm>
+          <a:prstGeom prst="rect">
+            <a:avLst/>
+          </a:prstGeom>
+          <a:noFill/>
+        </p:spPr>
+        <p:txBody>
+          <a:bodyPr wrap="square">
+            <a:spAutoFit/>
+          </a:bodyPr>
+          <a:lstStyle/>
+          <a:p>
+            <a:pPr algn="ctr">
+              <a:defRPr sz="600" i="1">
+                <a:solidFill>
+                  <a:srgbClr val="888888"/>
+                </a:solidFill>
+              </a:defRPr>
+            </a:pPr>
+            <a:r>
+              <a:t>Confidential – Not for Distribution  |  © 2026 Annabel Aaron. All rights reserved.</a:t>
+            </a:r>
           </a:p>
         </p:txBody>
       </p:sp>

</xml_diff>